<commit_message>
Add Response Action column to deck solution slide
Co-Authored-By: Claude Opus 5 (1M context) <noreply@anthropic.com>
Claude-Session: https://claude.ai/code/session_01Epk2t4dameKFXwak1LaenW
</commit_message>
<xml_diff>
--- a/deliverables/hack-team-05-pursuit-copilot-deck.pptx
+++ b/deliverables/hack-team-05-pursuit-copilot-deck.pptx
@@ -4800,6 +4800,25 @@
                 <a:spcPct val="105000"/>
               </a:lnSpc>
               <a:spcAft>
+                <a:spcPts val="900"/>
+              </a:spcAft>
+            </a:pPr>
+            <a:r>
+              <a:rPr sz="1400" b="0" i="0">
+                <a:solidFill>
+                  <a:srgbClr val="4A5A6E"/>
+                </a:solidFill>
+                <a:latin typeface="Calibri"/>
+              </a:rPr>
+              <a:t>First-draft copy for the opening sections, structured to the client's own required response items.</a:t>
+            </a:r>
+          </a:p>
+          <a:p>
+            <a:pPr algn="l">
+              <a:lnSpc>
+                <a:spcPct val="105000"/>
+              </a:lnSpc>
+              <a:spcAft>
                 <a:spcPts val="0"/>
               </a:spcAft>
             </a:pPr>
@@ -4810,7 +4829,7 @@
                 </a:solidFill>
                 <a:latin typeface="Calibri"/>
               </a:rPr>
-              <a:t>First-draft copy for the opening sections, structured to the client's own required response items.</a:t>
+              <a:t>A Response Action per requirement: what it asks of us.</a:t>
             </a:r>
           </a:p>
         </p:txBody>

</xml_diff>

<commit_message>
Add UI screenshot to demo slide
Slide 3's dashed placeholder is replaced with a real capture of the
pursuit workspace, committed at deliverables/assets/ui-workspace.png and
loaded relative to build_deck.py so the build stays reproducible. The
image is letterboxed inside the placeholder's rectangle with a thin navy
frame; the caption now names what it shows. Also drops the
"build in progress" line, renames the product to "Pursuit Copilot" to
match the app's own interface, and adds CJ's tagline under the title.

Co-Authored-By: Claude Opus 5 (1M context) <noreply@anthropic.com>
Claude-Session: https://claude.ai/code/session_01Epk2t4dameKFXwak1LaenW
</commit_message>
<xml_diff>
--- a/deliverables/hack-team-05-pursuit-copilot-deck.pptx
+++ b/deliverables/hack-team-05-pursuit-copilot-deck.pptx
@@ -3850,8 +3850,8 @@
         </p:nvSpPr>
         <p:spPr>
           <a:xfrm>
-            <a:off x="566928" y="786384"/>
-            <a:ext cx="7863840" cy="640080"/>
+            <a:off x="566928" y="768096"/>
+            <a:ext cx="7863840" cy="603504"/>
           </a:xfrm>
           <a:prstGeom prst="rect">
             <a:avLst/>
@@ -3876,7 +3876,7 @@
                 </a:solidFill>
                 <a:latin typeface="Calibri"/>
               </a:rPr>
-              <a:t>RFP Pursuit Copilot</a:t>
+              <a:t>Pursuit Copilot</a:t>
             </a:r>
           </a:p>
         </p:txBody>
@@ -3889,8 +3889,47 @@
         </p:nvSpPr>
         <p:spPr>
           <a:xfrm>
-            <a:off x="566928" y="1481328"/>
-            <a:ext cx="8503920" cy="585216"/>
+            <a:off x="566928" y="1371600"/>
+            <a:ext cx="8503920" cy="274320"/>
+          </a:xfrm>
+          <a:prstGeom prst="rect">
+            <a:avLst/>
+          </a:prstGeom>
+          <a:noFill/>
+        </p:spPr>
+        <p:txBody>
+          <a:bodyPr wrap="square" anchor="t" lIns="0" rIns="0" tIns="0" bIns="0">
+            <a:spAutoFit/>
+          </a:bodyPr>
+          <a:lstStyle/>
+          <a:p>
+            <a:pPr algn="l">
+              <a:lnSpc>
+                <a:spcPct val="100000"/>
+              </a:lnSpc>
+            </a:pPr>
+            <a:r>
+              <a:rPr sz="1700" b="1" i="0">
+                <a:solidFill>
+                  <a:srgbClr val="C0642A"/>
+                </a:solidFill>
+                <a:latin typeface="Calibri"/>
+              </a:rPr>
+              <a:t>Do the thinking that matters. Let AI handle the grind.</a:t>
+            </a:r>
+          </a:p>
+        </p:txBody>
+      </p:sp>
+      <p:sp>
+        <p:nvSpPr>
+          <p:cNvPr id="6" name="TextBox 5"/>
+          <p:cNvSpPr txBox="1"/>
+          <p:nvPr/>
+        </p:nvSpPr>
+        <p:spPr>
+          <a:xfrm>
+            <a:off x="566928" y="1700784"/>
+            <a:ext cx="8503920" cy="530352"/>
           </a:xfrm>
           <a:prstGeom prst="rect">
             <a:avLst/>
@@ -3922,13 +3961,13 @@
       </p:sp>
       <p:sp>
         <p:nvSpPr>
-          <p:cNvPr id="6" name="Rectangle 5"/>
+          <p:cNvPr id="7" name="Rectangle 6"/>
           <p:cNvSpPr/>
           <p:nvPr/>
         </p:nvSpPr>
         <p:spPr>
           <a:xfrm>
-            <a:off x="566928" y="2139696"/>
+            <a:off x="566928" y="2267712"/>
             <a:ext cx="1371600" cy="41148"/>
           </a:xfrm>
           <a:prstGeom prst="rect">
@@ -3966,13 +4005,13 @@
       </p:sp>
       <p:sp>
         <p:nvSpPr>
-          <p:cNvPr id="7" name="TextBox 6"/>
+          <p:cNvPr id="8" name="TextBox 7"/>
           <p:cNvSpPr txBox="1"/>
           <p:nvPr/>
         </p:nvSpPr>
         <p:spPr>
           <a:xfrm>
-            <a:off x="566928" y="2395728"/>
+            <a:off x="566928" y="2468880"/>
             <a:ext cx="10424160" cy="457200"/>
           </a:xfrm>
           <a:prstGeom prst="rect">
@@ -4005,13 +4044,13 @@
       </p:sp>
       <p:sp>
         <p:nvSpPr>
-          <p:cNvPr id="8" name="TextBox 7"/>
+          <p:cNvPr id="9" name="TextBox 8"/>
           <p:cNvSpPr txBox="1"/>
           <p:nvPr/>
         </p:nvSpPr>
         <p:spPr>
           <a:xfrm>
-            <a:off x="566928" y="2889504"/>
+            <a:off x="566928" y="2944368"/>
             <a:ext cx="10424160" cy="530352"/>
           </a:xfrm>
           <a:prstGeom prst="rect">
@@ -4044,7 +4083,7 @@
       </p:sp>
       <p:sp>
         <p:nvSpPr>
-          <p:cNvPr id="9" name="Rectangle 8"/>
+          <p:cNvPr id="10" name="Rectangle 9"/>
           <p:cNvSpPr/>
           <p:nvPr/>
         </p:nvSpPr>
@@ -4090,7 +4129,7 @@
       </p:sp>
       <p:sp>
         <p:nvSpPr>
-          <p:cNvPr id="10" name="TextBox 9"/>
+          <p:cNvPr id="11" name="TextBox 10"/>
           <p:cNvSpPr txBox="1"/>
           <p:nvPr/>
         </p:nvSpPr>
@@ -4148,7 +4187,7 @@
       </p:sp>
       <p:sp>
         <p:nvSpPr>
-          <p:cNvPr id="11" name="Rectangle 10"/>
+          <p:cNvPr id="12" name="Rectangle 11"/>
           <p:cNvSpPr/>
           <p:nvPr/>
         </p:nvSpPr>
@@ -4194,7 +4233,7 @@
       </p:sp>
       <p:sp>
         <p:nvSpPr>
-          <p:cNvPr id="12" name="TextBox 11"/>
+          <p:cNvPr id="13" name="TextBox 12"/>
           <p:cNvSpPr txBox="1"/>
           <p:nvPr/>
         </p:nvSpPr>
@@ -4252,7 +4291,7 @@
       </p:sp>
       <p:sp>
         <p:nvSpPr>
-          <p:cNvPr id="13" name="Rectangle 12"/>
+          <p:cNvPr id="14" name="Rectangle 13"/>
           <p:cNvSpPr/>
           <p:nvPr/>
         </p:nvSpPr>
@@ -4298,7 +4337,7 @@
       </p:sp>
       <p:sp>
         <p:nvSpPr>
-          <p:cNvPr id="14" name="TextBox 13"/>
+          <p:cNvPr id="15" name="TextBox 14"/>
           <p:cNvSpPr txBox="1"/>
           <p:nvPr/>
         </p:nvSpPr>
@@ -4356,7 +4395,7 @@
       </p:sp>
       <p:sp>
         <p:nvSpPr>
-          <p:cNvPr id="15" name="Rectangle 14"/>
+          <p:cNvPr id="16" name="Rectangle 15"/>
           <p:cNvSpPr/>
           <p:nvPr/>
         </p:nvSpPr>
@@ -4400,7 +4439,7 @@
       </p:sp>
       <p:sp>
         <p:nvSpPr>
-          <p:cNvPr id="16" name="Rectangle 15"/>
+          <p:cNvPr id="17" name="Rectangle 16"/>
           <p:cNvSpPr/>
           <p:nvPr/>
         </p:nvSpPr>
@@ -4444,7 +4483,7 @@
       </p:sp>
       <p:sp>
         <p:nvSpPr>
-          <p:cNvPr id="17" name="TextBox 16"/>
+          <p:cNvPr id="18" name="TextBox 17"/>
           <p:cNvSpPr txBox="1"/>
           <p:nvPr/>
         </p:nvSpPr>
@@ -4502,7 +4541,7 @@
       </p:sp>
       <p:sp>
         <p:nvSpPr>
-          <p:cNvPr id="18" name="TextBox 17"/>
+          <p:cNvPr id="19" name="TextBox 18"/>
           <p:cNvSpPr txBox="1"/>
           <p:nvPr/>
         </p:nvSpPr>
@@ -4627,7 +4666,7 @@
                 </a:solidFill>
                 <a:latin typeface="Calibri"/>
               </a:rPr>
-              <a:t>THE SOLUTION  ·  RFP PURSUIT COPILOT</a:t>
+              <a:t>THE SOLUTION  ·  PURSUIT COPILOT</a:t>
             </a:r>
           </a:p>
         </p:txBody>
@@ -6529,28 +6568,49 @@
           </a:p>
         </p:txBody>
       </p:sp>
-      <p:sp>
-        <p:nvSpPr>
-          <p:cNvPr id="25" name="Rectangle 24"/>
+      <p:pic>
+        <p:nvPicPr>
+          <p:cNvPr id="25" name="Picture 24" descr="ui-workspace.png"/>
+          <p:cNvPicPr>
+            <a:picLocks noChangeAspect="1"/>
+          </p:cNvPicPr>
+          <p:nvPr/>
+        </p:nvPicPr>
+        <p:blipFill>
+          <a:blip r:embed="rId2"/>
+          <a:stretch>
+            <a:fillRect/>
+          </a:stretch>
+        </p:blipFill>
+        <p:spPr>
+          <a:xfrm>
+            <a:off x="7443216" y="1773936"/>
+            <a:ext cx="4178808" cy="3365840"/>
+          </a:xfrm>
+          <a:prstGeom prst="rect">
+            <a:avLst/>
+          </a:prstGeom>
+        </p:spPr>
+      </p:pic>
+      <p:sp>
+        <p:nvSpPr>
+          <p:cNvPr id="26" name="Rectangle 25"/>
           <p:cNvSpPr/>
           <p:nvPr/>
         </p:nvSpPr>
         <p:spPr>
           <a:xfrm>
             <a:off x="7443216" y="1773936"/>
-            <a:ext cx="4178808" cy="4059936"/>
-          </a:xfrm>
-          <a:prstGeom prst="rect">
-            <a:avLst/>
-          </a:prstGeom>
-          <a:solidFill>
-            <a:srgbClr val="F1F4F7"/>
-          </a:solidFill>
-          <a:ln w="15875">
+            <a:ext cx="4178808" cy="3365840"/>
+          </a:xfrm>
+          <a:prstGeom prst="rect">
+            <a:avLst/>
+          </a:prstGeom>
+          <a:noFill/>
+          <a:ln w="12700">
             <a:solidFill>
-              <a:srgbClr val="4A5A6E"/>
+              <a:srgbClr val="0F2540"/>
             </a:solidFill>
-            <a:prstDash val="dash"/>
           </a:ln>
           <a:effectLst/>
         </p:spPr>
@@ -6578,14 +6638,14 @@
       </p:sp>
       <p:sp>
         <p:nvSpPr>
-          <p:cNvPr id="26" name="TextBox 25"/>
+          <p:cNvPr id="27" name="TextBox 26"/>
           <p:cNvSpPr txBox="1"/>
           <p:nvPr/>
         </p:nvSpPr>
         <p:spPr>
           <a:xfrm>
-            <a:off x="7717536" y="3474720"/>
-            <a:ext cx="3630168" cy="914400"/>
+            <a:off x="7443216" y="5286080"/>
+            <a:ext cx="4178808" cy="640080"/>
           </a:xfrm>
           <a:prstGeom prst="rect">
             <a:avLst/>
@@ -6599,65 +6659,18 @@
           <a:lstStyle/>
           <a:p>
             <a:pPr algn="ctr">
-              <a:spcAft>
-                <a:spcPts val="700"/>
-              </a:spcAft>
+              <a:lnSpc>
+                <a:spcPct val="110000"/>
+              </a:lnSpc>
             </a:pPr>
             <a:r>
-              <a:rPr sz="1400" b="1" i="0">
+              <a:rPr sz="1200" b="0" i="0">
                 <a:solidFill>
                   <a:srgbClr val="4A5A6E"/>
                 </a:solidFill>
                 <a:latin typeface="Calibri"/>
               </a:rPr>
-              <a:t>[ Screenshot: paste UI capture here ]</a:t>
-            </a:r>
-          </a:p>
-          <a:p>
-            <a:pPr algn="ctr"/>
-            <a:r>
-              <a:rPr sz="1200" b="0" i="1">
-                <a:solidFill>
-                  <a:srgbClr val="4A5A6E"/>
-                </a:solidFill>
-                <a:latin typeface="Calibri"/>
-              </a:rPr>
-              <a:t>Front end built; backend in progress at time of writing.</a:t>
-            </a:r>
-          </a:p>
-        </p:txBody>
-      </p:sp>
-      <p:sp>
-        <p:nvSpPr>
-          <p:cNvPr id="27" name="TextBox 26"/>
-          <p:cNvSpPr txBox="1"/>
-          <p:nvPr/>
-        </p:nvSpPr>
-        <p:spPr>
-          <a:xfrm>
-            <a:off x="7443216" y="5980176"/>
-            <a:ext cx="4178808" cy="274320"/>
-          </a:xfrm>
-          <a:prstGeom prst="rect">
-            <a:avLst/>
-          </a:prstGeom>
-          <a:noFill/>
-        </p:spPr>
-        <p:txBody>
-          <a:bodyPr wrap="square" anchor="t" lIns="0" rIns="0" tIns="0" bIns="0">
-            <a:spAutoFit/>
-          </a:bodyPr>
-          <a:lstStyle/>
-          <a:p>
-            <a:pPr algn="ctr"/>
-            <a:r>
-              <a:rPr sz="1200" b="0" i="0">
-                <a:solidFill>
-                  <a:srgbClr val="4A5A6E"/>
-                </a:solidFill>
-                <a:latin typeface="Calibri"/>
-              </a:rPr>
-              <a:t>Live walkthrough delivered in the demo slot.</a:t>
+              <a:t>The pursuit workspace: the five engines — Understand, Strategize, Match, Design, Create — and the requirements bucket they produce.</a:t>
             </a:r>
           </a:p>
         </p:txBody>

</xml_diff>